<commit_message>
Midterm deck updated with results, in the proposal's own design
Built from the proposal slides as templates (shapes, fonts, geometry copied),
23 slides: architecture replaced by the paper's Figure 1; tables are crops of
the compiled paper; figures from results/. Proposal-era claims (adversarial
disentanglement, conformal guarantee, motion R2) replaced by the outcomes.
Rebuild after new results: crop_paper_assets.py then build_midterm_updated.py.

Co-Authored-By: Claude Opus 5 (1M context) <noreply@anthropic.com>
</commit_message>
<xml_diff>
--- a/presentation/CALM-Net_midterm_proposal.pptx
+++ b/presentation/CALM-Net_midterm_proposal.pptx
@@ -5,19 +5,19 @@
     <p:sldMasterId id="2147483648" r:id="rId1"/>
   </p:sldMasterIdLst>
   <p:sldIdLst>
-    <p:sldId id="256" r:id="rId7"/>
-    <p:sldId id="257" r:id="rId8"/>
-    <p:sldId id="258" r:id="rId9"/>
-    <p:sldId id="259" r:id="rId10"/>
-    <p:sldId id="260" r:id="rId11"/>
-    <p:sldId id="261" r:id="rId12"/>
-    <p:sldId id="262" r:id="rId13"/>
-    <p:sldId id="263" r:id="rId14"/>
-    <p:sldId id="264" r:id="rId15"/>
-    <p:sldId id="265" r:id="rId16"/>
-    <p:sldId id="266" r:id="rId17"/>
+    <p:sldId id="256" r:id="rId2"/>
+    <p:sldId id="257" r:id="rId3"/>
+    <p:sldId id="258" r:id="rId4"/>
+    <p:sldId id="259" r:id="rId5"/>
+    <p:sldId id="260" r:id="rId6"/>
+    <p:sldId id="261" r:id="rId7"/>
+    <p:sldId id="262" r:id="rId8"/>
+    <p:sldId id="263" r:id="rId9"/>
+    <p:sldId id="264" r:id="rId10"/>
+    <p:sldId id="265" r:id="rId11"/>
+    <p:sldId id="266" r:id="rId12"/>
   </p:sldIdLst>
-  <p:sldSz cx="12191695" cy="6858000" type="screen4x3"/>
+  <p:sldSz cx="12192000" cy="6858000"/>
   <p:notesSz cx="6858000" cy="9144000"/>
   <p:defaultTextStyle>
     <a:defPPr>
@@ -114,6 +114,22 @@
       </a:defRPr>
     </a:lvl9pPr>
   </p:defaultTextStyle>
+  <p:extLst>
+    <p:ext uri="{EFAFB233-063F-42B5-8137-9DF3F51BA10A}">
+      <p15:sldGuideLst xmlns:p15="http://schemas.microsoft.com/office/powerpoint/2012/main">
+        <p15:guide id="1" orient="horz" pos="2160">
+          <p15:clr>
+            <a:srgbClr val="A4A3A4"/>
+          </p15:clr>
+        </p15:guide>
+        <p15:guide id="2" pos="2880">
+          <p15:clr>
+            <a:srgbClr val="A4A3A4"/>
+          </p15:clr>
+        </p15:guide>
+      </p15:sldGuideLst>
+    </p:ext>
+  </p:extLst>
 </p:presentation>
 </file>
 
@@ -155,10 +171,9 @@
           <a:lstStyle/>
           <a:p>
             <a:r>
-              <a:rPr lang="en-US" smtClean="0"/>
+              <a:rPr lang="en-US"/>
               <a:t>Click to edit Master title style</a:t>
             </a:r>
-            <a:endParaRPr lang="en-US"/>
           </a:p>
         </p:txBody>
       </p:sp>
@@ -274,10 +289,9 @@
           </a:lstStyle>
           <a:p>
             <a:r>
-              <a:rPr lang="en-US" smtClean="0"/>
+              <a:rPr lang="en-US"/>
               <a:t>Click to edit Master subtitle style</a:t>
             </a:r>
-            <a:endParaRPr lang="en-US"/>
           </a:p>
         </p:txBody>
       </p:sp>
@@ -298,7 +312,7 @@
           <a:p>
             <a:fld id="{5BCAD085-E8A6-8845-BD4E-CB4CCA059FC4}" type="datetimeFigureOut">
               <a:rPr lang="en-US" smtClean="0"/>
-              <a:t>1/27/13</a:t>
+              <a:t>9/17/2026</a:t>
             </a:fld>
             <a:endParaRPr lang="en-US"/>
           </a:p>
@@ -392,10 +406,9 @@
           <a:lstStyle/>
           <a:p>
             <a:r>
-              <a:rPr lang="en-US" smtClean="0"/>
+              <a:rPr lang="en-US"/>
               <a:t>Click to edit Master title style</a:t>
             </a:r>
-            <a:endParaRPr lang="en-US"/>
           </a:p>
         </p:txBody>
       </p:sp>
@@ -416,38 +429,37 @@
           <a:p>
             <a:pPr lvl="0"/>
             <a:r>
-              <a:rPr lang="en-US" smtClean="0"/>
+              <a:rPr lang="en-US"/>
               <a:t>Click to edit Master text styles</a:t>
             </a:r>
           </a:p>
           <a:p>
             <a:pPr lvl="1"/>
             <a:r>
-              <a:rPr lang="en-US" smtClean="0"/>
+              <a:rPr lang="en-US"/>
               <a:t>Second level</a:t>
             </a:r>
           </a:p>
           <a:p>
             <a:pPr lvl="2"/>
             <a:r>
-              <a:rPr lang="en-US" smtClean="0"/>
+              <a:rPr lang="en-US"/>
               <a:t>Third level</a:t>
             </a:r>
           </a:p>
           <a:p>
             <a:pPr lvl="3"/>
             <a:r>
-              <a:rPr lang="en-US" smtClean="0"/>
+              <a:rPr lang="en-US"/>
               <a:t>Fourth level</a:t>
             </a:r>
           </a:p>
           <a:p>
             <a:pPr lvl="4"/>
             <a:r>
-              <a:rPr lang="en-US" smtClean="0"/>
+              <a:rPr lang="en-US"/>
               <a:t>Fifth level</a:t>
             </a:r>
-            <a:endParaRPr lang="en-US"/>
           </a:p>
         </p:txBody>
       </p:sp>
@@ -468,7 +480,7 @@
           <a:p>
             <a:fld id="{5BCAD085-E8A6-8845-BD4E-CB4CCA059FC4}" type="datetimeFigureOut">
               <a:rPr lang="en-US" smtClean="0"/>
-              <a:t>1/27/13</a:t>
+              <a:t>9/17/2026</a:t>
             </a:fld>
             <a:endParaRPr lang="en-US"/>
           </a:p>
@@ -567,10 +579,9 @@
           <a:lstStyle/>
           <a:p>
             <a:r>
-              <a:rPr lang="en-US" smtClean="0"/>
+              <a:rPr lang="en-US"/>
               <a:t>Click to edit Master title style</a:t>
             </a:r>
-            <a:endParaRPr lang="en-US"/>
           </a:p>
         </p:txBody>
       </p:sp>
@@ -596,38 +607,37 @@
           <a:p>
             <a:pPr lvl="0"/>
             <a:r>
-              <a:rPr lang="en-US" smtClean="0"/>
+              <a:rPr lang="en-US"/>
               <a:t>Click to edit Master text styles</a:t>
             </a:r>
           </a:p>
           <a:p>
             <a:pPr lvl="1"/>
             <a:r>
-              <a:rPr lang="en-US" smtClean="0"/>
+              <a:rPr lang="en-US"/>
               <a:t>Second level</a:t>
             </a:r>
           </a:p>
           <a:p>
             <a:pPr lvl="2"/>
             <a:r>
-              <a:rPr lang="en-US" smtClean="0"/>
+              <a:rPr lang="en-US"/>
               <a:t>Third level</a:t>
             </a:r>
           </a:p>
           <a:p>
             <a:pPr lvl="3"/>
             <a:r>
-              <a:rPr lang="en-US" smtClean="0"/>
+              <a:rPr lang="en-US"/>
               <a:t>Fourth level</a:t>
             </a:r>
           </a:p>
           <a:p>
             <a:pPr lvl="4"/>
             <a:r>
-              <a:rPr lang="en-US" smtClean="0"/>
+              <a:rPr lang="en-US"/>
               <a:t>Fifth level</a:t>
             </a:r>
-            <a:endParaRPr lang="en-US"/>
           </a:p>
         </p:txBody>
       </p:sp>
@@ -648,7 +658,7 @@
           <a:p>
             <a:fld id="{5BCAD085-E8A6-8845-BD4E-CB4CCA059FC4}" type="datetimeFigureOut">
               <a:rPr lang="en-US" smtClean="0"/>
-              <a:t>1/27/13</a:t>
+              <a:t>9/17/2026</a:t>
             </a:fld>
             <a:endParaRPr lang="en-US"/>
           </a:p>
@@ -742,10 +752,9 @@
           <a:lstStyle/>
           <a:p>
             <a:r>
-              <a:rPr lang="en-US" smtClean="0"/>
+              <a:rPr lang="en-US"/>
               <a:t>Click to edit Master title style</a:t>
             </a:r>
-            <a:endParaRPr lang="en-US"/>
           </a:p>
         </p:txBody>
       </p:sp>
@@ -766,38 +775,37 @@
           <a:p>
             <a:pPr lvl="0"/>
             <a:r>
-              <a:rPr lang="en-US" smtClean="0"/>
+              <a:rPr lang="en-US"/>
               <a:t>Click to edit Master text styles</a:t>
             </a:r>
           </a:p>
           <a:p>
             <a:pPr lvl="1"/>
             <a:r>
-              <a:rPr lang="en-US" smtClean="0"/>
+              <a:rPr lang="en-US"/>
               <a:t>Second level</a:t>
             </a:r>
           </a:p>
           <a:p>
             <a:pPr lvl="2"/>
             <a:r>
-              <a:rPr lang="en-US" smtClean="0"/>
+              <a:rPr lang="en-US"/>
               <a:t>Third level</a:t>
             </a:r>
           </a:p>
           <a:p>
             <a:pPr lvl="3"/>
             <a:r>
-              <a:rPr lang="en-US" smtClean="0"/>
+              <a:rPr lang="en-US"/>
               <a:t>Fourth level</a:t>
             </a:r>
           </a:p>
           <a:p>
             <a:pPr lvl="4"/>
             <a:r>
-              <a:rPr lang="en-US" smtClean="0"/>
+              <a:rPr lang="en-US"/>
               <a:t>Fifth level</a:t>
             </a:r>
-            <a:endParaRPr lang="en-US"/>
           </a:p>
         </p:txBody>
       </p:sp>
@@ -818,7 +826,7 @@
           <a:p>
             <a:fld id="{5BCAD085-E8A6-8845-BD4E-CB4CCA059FC4}" type="datetimeFigureOut">
               <a:rPr lang="en-US" smtClean="0"/>
-              <a:t>1/27/13</a:t>
+              <a:t>9/17/2026</a:t>
             </a:fld>
             <a:endParaRPr lang="en-US"/>
           </a:p>
@@ -921,10 +929,9 @@
           </a:lstStyle>
           <a:p>
             <a:r>
-              <a:rPr lang="en-US" smtClean="0"/>
+              <a:rPr lang="en-US"/>
               <a:t>Click to edit Master title style</a:t>
             </a:r>
-            <a:endParaRPr lang="en-US"/>
           </a:p>
         </p:txBody>
       </p:sp>
@@ -1041,7 +1048,7 @@
           <a:p>
             <a:pPr lvl="0"/>
             <a:r>
-              <a:rPr lang="en-US" smtClean="0"/>
+              <a:rPr lang="en-US"/>
               <a:t>Click to edit Master text styles</a:t>
             </a:r>
           </a:p>
@@ -1064,7 +1071,7 @@
           <a:p>
             <a:fld id="{5BCAD085-E8A6-8845-BD4E-CB4CCA059FC4}" type="datetimeFigureOut">
               <a:rPr lang="en-US" smtClean="0"/>
-              <a:t>1/27/13</a:t>
+              <a:t>9/17/2026</a:t>
             </a:fld>
             <a:endParaRPr lang="en-US"/>
           </a:p>
@@ -1158,10 +1165,9 @@
           <a:lstStyle/>
           <a:p>
             <a:r>
-              <a:rPr lang="en-US" smtClean="0"/>
+              <a:rPr lang="en-US"/>
               <a:t>Click to edit Master title style</a:t>
             </a:r>
-            <a:endParaRPr lang="en-US"/>
           </a:p>
         </p:txBody>
       </p:sp>
@@ -1215,38 +1221,37 @@
           <a:p>
             <a:pPr lvl="0"/>
             <a:r>
-              <a:rPr lang="en-US" smtClean="0"/>
+              <a:rPr lang="en-US"/>
               <a:t>Click to edit Master text styles</a:t>
             </a:r>
           </a:p>
           <a:p>
             <a:pPr lvl="1"/>
             <a:r>
-              <a:rPr lang="en-US" smtClean="0"/>
+              <a:rPr lang="en-US"/>
               <a:t>Second level</a:t>
             </a:r>
           </a:p>
           <a:p>
             <a:pPr lvl="2"/>
             <a:r>
-              <a:rPr lang="en-US" smtClean="0"/>
+              <a:rPr lang="en-US"/>
               <a:t>Third level</a:t>
             </a:r>
           </a:p>
           <a:p>
             <a:pPr lvl="3"/>
             <a:r>
-              <a:rPr lang="en-US" smtClean="0"/>
+              <a:rPr lang="en-US"/>
               <a:t>Fourth level</a:t>
             </a:r>
           </a:p>
           <a:p>
             <a:pPr lvl="4"/>
             <a:r>
-              <a:rPr lang="en-US" smtClean="0"/>
+              <a:rPr lang="en-US"/>
               <a:t>Fifth level</a:t>
             </a:r>
-            <a:endParaRPr lang="en-US"/>
           </a:p>
         </p:txBody>
       </p:sp>
@@ -1300,38 +1305,37 @@
           <a:p>
             <a:pPr lvl="0"/>
             <a:r>
-              <a:rPr lang="en-US" smtClean="0"/>
+              <a:rPr lang="en-US"/>
               <a:t>Click to edit Master text styles</a:t>
             </a:r>
           </a:p>
           <a:p>
             <a:pPr lvl="1"/>
             <a:r>
-              <a:rPr lang="en-US" smtClean="0"/>
+              <a:rPr lang="en-US"/>
               <a:t>Second level</a:t>
             </a:r>
           </a:p>
           <a:p>
             <a:pPr lvl="2"/>
             <a:r>
-              <a:rPr lang="en-US" smtClean="0"/>
+              <a:rPr lang="en-US"/>
               <a:t>Third level</a:t>
             </a:r>
           </a:p>
           <a:p>
             <a:pPr lvl="3"/>
             <a:r>
-              <a:rPr lang="en-US" smtClean="0"/>
+              <a:rPr lang="en-US"/>
               <a:t>Fourth level</a:t>
             </a:r>
           </a:p>
           <a:p>
             <a:pPr lvl="4"/>
             <a:r>
-              <a:rPr lang="en-US" smtClean="0"/>
+              <a:rPr lang="en-US"/>
               <a:t>Fifth level</a:t>
             </a:r>
-            <a:endParaRPr lang="en-US"/>
           </a:p>
         </p:txBody>
       </p:sp>
@@ -1352,7 +1356,7 @@
           <a:p>
             <a:fld id="{5BCAD085-E8A6-8845-BD4E-CB4CCA059FC4}" type="datetimeFigureOut">
               <a:rPr lang="en-US" smtClean="0"/>
-              <a:t>1/27/13</a:t>
+              <a:t>9/17/2026</a:t>
             </a:fld>
             <a:endParaRPr lang="en-US"/>
           </a:p>
@@ -1450,10 +1454,9 @@
           </a:lstStyle>
           <a:p>
             <a:r>
-              <a:rPr lang="en-US" smtClean="0"/>
+              <a:rPr lang="en-US"/>
               <a:t>Click to edit Master title style</a:t>
             </a:r>
-            <a:endParaRPr lang="en-US"/>
           </a:p>
         </p:txBody>
       </p:sp>
@@ -1516,7 +1519,7 @@
           <a:p>
             <a:pPr lvl="0"/>
             <a:r>
-              <a:rPr lang="en-US" smtClean="0"/>
+              <a:rPr lang="en-US"/>
               <a:t>Click to edit Master text styles</a:t>
             </a:r>
           </a:p>
@@ -1572,38 +1575,37 @@
           <a:p>
             <a:pPr lvl="0"/>
             <a:r>
-              <a:rPr lang="en-US" smtClean="0"/>
+              <a:rPr lang="en-US"/>
               <a:t>Click to edit Master text styles</a:t>
             </a:r>
           </a:p>
           <a:p>
             <a:pPr lvl="1"/>
             <a:r>
-              <a:rPr lang="en-US" smtClean="0"/>
+              <a:rPr lang="en-US"/>
               <a:t>Second level</a:t>
             </a:r>
           </a:p>
           <a:p>
             <a:pPr lvl="2"/>
             <a:r>
-              <a:rPr lang="en-US" smtClean="0"/>
+              <a:rPr lang="en-US"/>
               <a:t>Third level</a:t>
             </a:r>
           </a:p>
           <a:p>
             <a:pPr lvl="3"/>
             <a:r>
-              <a:rPr lang="en-US" smtClean="0"/>
+              <a:rPr lang="en-US"/>
               <a:t>Fourth level</a:t>
             </a:r>
           </a:p>
           <a:p>
             <a:pPr lvl="4"/>
             <a:r>
-              <a:rPr lang="en-US" smtClean="0"/>
+              <a:rPr lang="en-US"/>
               <a:t>Fifth level</a:t>
             </a:r>
-            <a:endParaRPr lang="en-US"/>
           </a:p>
         </p:txBody>
       </p:sp>
@@ -1666,7 +1668,7 @@
           <a:p>
             <a:pPr lvl="0"/>
             <a:r>
-              <a:rPr lang="en-US" smtClean="0"/>
+              <a:rPr lang="en-US"/>
               <a:t>Click to edit Master text styles</a:t>
             </a:r>
           </a:p>
@@ -1722,38 +1724,37 @@
           <a:p>
             <a:pPr lvl="0"/>
             <a:r>
-              <a:rPr lang="en-US" smtClean="0"/>
+              <a:rPr lang="en-US"/>
               <a:t>Click to edit Master text styles</a:t>
             </a:r>
           </a:p>
           <a:p>
             <a:pPr lvl="1"/>
             <a:r>
-              <a:rPr lang="en-US" smtClean="0"/>
+              <a:rPr lang="en-US"/>
               <a:t>Second level</a:t>
             </a:r>
           </a:p>
           <a:p>
             <a:pPr lvl="2"/>
             <a:r>
-              <a:rPr lang="en-US" smtClean="0"/>
+              <a:rPr lang="en-US"/>
               <a:t>Third level</a:t>
             </a:r>
           </a:p>
           <a:p>
             <a:pPr lvl="3"/>
             <a:r>
-              <a:rPr lang="en-US" smtClean="0"/>
+              <a:rPr lang="en-US"/>
               <a:t>Fourth level</a:t>
             </a:r>
           </a:p>
           <a:p>
             <a:pPr lvl="4"/>
             <a:r>
-              <a:rPr lang="en-US" smtClean="0"/>
+              <a:rPr lang="en-US"/>
               <a:t>Fifth level</a:t>
             </a:r>
-            <a:endParaRPr lang="en-US"/>
           </a:p>
         </p:txBody>
       </p:sp>
@@ -1774,7 +1775,7 @@
           <a:p>
             <a:fld id="{5BCAD085-E8A6-8845-BD4E-CB4CCA059FC4}" type="datetimeFigureOut">
               <a:rPr lang="en-US" smtClean="0"/>
-              <a:t>1/27/13</a:t>
+              <a:t>9/17/2026</a:t>
             </a:fld>
             <a:endParaRPr lang="en-US"/>
           </a:p>
@@ -1868,10 +1869,9 @@
           <a:lstStyle/>
           <a:p>
             <a:r>
-              <a:rPr lang="en-US" smtClean="0"/>
+              <a:rPr lang="en-US"/>
               <a:t>Click to edit Master title style</a:t>
             </a:r>
-            <a:endParaRPr lang="en-US"/>
           </a:p>
         </p:txBody>
       </p:sp>
@@ -1892,7 +1892,7 @@
           <a:p>
             <a:fld id="{5BCAD085-E8A6-8845-BD4E-CB4CCA059FC4}" type="datetimeFigureOut">
               <a:rPr lang="en-US" smtClean="0"/>
-              <a:t>1/27/13</a:t>
+              <a:t>9/17/2026</a:t>
             </a:fld>
             <a:endParaRPr lang="en-US"/>
           </a:p>
@@ -1987,7 +1987,7 @@
           <a:p>
             <a:fld id="{5BCAD085-E8A6-8845-BD4E-CB4CCA059FC4}" type="datetimeFigureOut">
               <a:rPr lang="en-US" smtClean="0"/>
-              <a:t>1/27/13</a:t>
+              <a:t>9/17/2026</a:t>
             </a:fld>
             <a:endParaRPr lang="en-US"/>
           </a:p>
@@ -2090,10 +2090,9 @@
           </a:lstStyle>
           <a:p>
             <a:r>
-              <a:rPr lang="en-US" smtClean="0"/>
+              <a:rPr lang="en-US"/>
               <a:t>Click to edit Master title style</a:t>
             </a:r>
-            <a:endParaRPr lang="en-US"/>
           </a:p>
         </p:txBody>
       </p:sp>
@@ -2147,38 +2146,37 @@
           <a:p>
             <a:pPr lvl="0"/>
             <a:r>
-              <a:rPr lang="en-US" smtClean="0"/>
+              <a:rPr lang="en-US"/>
               <a:t>Click to edit Master text styles</a:t>
             </a:r>
           </a:p>
           <a:p>
             <a:pPr lvl="1"/>
             <a:r>
-              <a:rPr lang="en-US" smtClean="0"/>
+              <a:rPr lang="en-US"/>
               <a:t>Second level</a:t>
             </a:r>
           </a:p>
           <a:p>
             <a:pPr lvl="2"/>
             <a:r>
-              <a:rPr lang="en-US" smtClean="0"/>
+              <a:rPr lang="en-US"/>
               <a:t>Third level</a:t>
             </a:r>
           </a:p>
           <a:p>
             <a:pPr lvl="3"/>
             <a:r>
-              <a:rPr lang="en-US" smtClean="0"/>
+              <a:rPr lang="en-US"/>
               <a:t>Fourth level</a:t>
             </a:r>
           </a:p>
           <a:p>
             <a:pPr lvl="4"/>
             <a:r>
-              <a:rPr lang="en-US" smtClean="0"/>
+              <a:rPr lang="en-US"/>
               <a:t>Fifth level</a:t>
             </a:r>
-            <a:endParaRPr lang="en-US"/>
           </a:p>
         </p:txBody>
       </p:sp>
@@ -2241,7 +2239,7 @@
           <a:p>
             <a:pPr lvl="0"/>
             <a:r>
-              <a:rPr lang="en-US" smtClean="0"/>
+              <a:rPr lang="en-US"/>
               <a:t>Click to edit Master text styles</a:t>
             </a:r>
           </a:p>
@@ -2264,7 +2262,7 @@
           <a:p>
             <a:fld id="{5BCAD085-E8A6-8845-BD4E-CB4CCA059FC4}" type="datetimeFigureOut">
               <a:rPr lang="en-US" smtClean="0"/>
-              <a:t>1/27/13</a:t>
+              <a:t>9/17/2026</a:t>
             </a:fld>
             <a:endParaRPr lang="en-US"/>
           </a:p>
@@ -2367,10 +2365,9 @@
           </a:lstStyle>
           <a:p>
             <a:r>
-              <a:rPr lang="en-US" smtClean="0"/>
+              <a:rPr lang="en-US"/>
               <a:t>Click to edit Master title style</a:t>
             </a:r>
-            <a:endParaRPr lang="en-US"/>
           </a:p>
         </p:txBody>
       </p:sp>
@@ -2494,7 +2491,7 @@
           <a:p>
             <a:pPr lvl="0"/>
             <a:r>
-              <a:rPr lang="en-US" smtClean="0"/>
+              <a:rPr lang="en-US"/>
               <a:t>Click to edit Master text styles</a:t>
             </a:r>
           </a:p>
@@ -2517,7 +2514,7 @@
           <a:p>
             <a:fld id="{5BCAD085-E8A6-8845-BD4E-CB4CCA059FC4}" type="datetimeFigureOut">
               <a:rPr lang="en-US" smtClean="0"/>
-              <a:t>1/27/13</a:t>
+              <a:t>9/17/2026</a:t>
             </a:fld>
             <a:endParaRPr lang="en-US"/>
           </a:p>
@@ -2626,10 +2623,9 @@
           <a:lstStyle/>
           <a:p>
             <a:r>
-              <a:rPr lang="en-US" smtClean="0"/>
+              <a:rPr lang="en-US"/>
               <a:t>Click to edit Master title style</a:t>
             </a:r>
-            <a:endParaRPr lang="en-US"/>
           </a:p>
         </p:txBody>
       </p:sp>
@@ -2660,38 +2656,37 @@
           <a:p>
             <a:pPr lvl="0"/>
             <a:r>
-              <a:rPr lang="en-US" smtClean="0"/>
+              <a:rPr lang="en-US"/>
               <a:t>Click to edit Master text styles</a:t>
             </a:r>
           </a:p>
           <a:p>
             <a:pPr lvl="1"/>
             <a:r>
-              <a:rPr lang="en-US" smtClean="0"/>
+              <a:rPr lang="en-US"/>
               <a:t>Second level</a:t>
             </a:r>
           </a:p>
           <a:p>
             <a:pPr lvl="2"/>
             <a:r>
-              <a:rPr lang="en-US" smtClean="0"/>
+              <a:rPr lang="en-US"/>
               <a:t>Third level</a:t>
             </a:r>
           </a:p>
           <a:p>
             <a:pPr lvl="3"/>
             <a:r>
-              <a:rPr lang="en-US" smtClean="0"/>
+              <a:rPr lang="en-US"/>
               <a:t>Fourth level</a:t>
             </a:r>
           </a:p>
           <a:p>
             <a:pPr lvl="4"/>
             <a:r>
-              <a:rPr lang="en-US" smtClean="0"/>
+              <a:rPr lang="en-US"/>
               <a:t>Fifth level</a:t>
             </a:r>
-            <a:endParaRPr lang="en-US"/>
           </a:p>
         </p:txBody>
       </p:sp>
@@ -2730,7 +2725,7 @@
           <a:p>
             <a:fld id="{5BCAD085-E8A6-8845-BD4E-CB4CCA059FC4}" type="datetimeFigureOut">
               <a:rPr lang="en-US" smtClean="0"/>
-              <a:t>1/27/13</a:t>
+              <a:t>9/17/2026</a:t>
             </a:fld>
             <a:endParaRPr lang="en-US"/>
           </a:p>
@@ -3089,7 +3084,7 @@
 </file>
 
 <file path=ppt/slides/slide1.xml><?xml version="1.0" encoding="utf-8"?>
-<p:sld xmlns:a="http://schemas.openxmlformats.org/drawingml/2006/main" xmlns:p="http://schemas.openxmlformats.org/presentationml/2006/main" xmlns:r="http://schemas.openxmlformats.org/officeDocument/2006/relationships">
+<p:sld xmlns:a="http://schemas.openxmlformats.org/drawingml/2006/main" xmlns:r="http://schemas.openxmlformats.org/officeDocument/2006/relationships" xmlns:p="http://schemas.openxmlformats.org/presentationml/2006/main">
   <p:cSld>
     <p:spTree>
       <p:nvGrpSpPr>
@@ -3097,7 +3092,14 @@
         <p:cNvGrpSpPr/>
         <p:nvPr/>
       </p:nvGrpSpPr>
-      <p:grpSpPr/>
+      <p:grpSpPr>
+        <a:xfrm>
+          <a:off x="0" y="0"/>
+          <a:ext cx="0" cy="0"/>
+          <a:chOff x="0" y="0"/>
+          <a:chExt cx="0" cy="0"/>
+        </a:xfrm>
+      </p:grpSpPr>
       <p:sp>
         <p:nvSpPr>
           <p:cNvPr id="2" name="Rectangle 1"/>
@@ -3139,6 +3141,7 @@
           <a:lstStyle/>
           <a:p>
             <a:pPr algn="ctr"/>
+            <a:endParaRPr/>
           </a:p>
         </p:txBody>
       </p:sp>
@@ -3225,6 +3228,7 @@
           <a:lstStyle/>
           <a:p>
             <a:pPr algn="ctr"/>
+            <a:endParaRPr/>
           </a:p>
         </p:txBody>
       </p:sp>
@@ -3340,7 +3344,7 @@
 </file>
 
 <file path=ppt/slides/slide10.xml><?xml version="1.0" encoding="utf-8"?>
-<p:sld xmlns:a="http://schemas.openxmlformats.org/drawingml/2006/main" xmlns:p="http://schemas.openxmlformats.org/presentationml/2006/main" xmlns:r="http://schemas.openxmlformats.org/officeDocument/2006/relationships">
+<p:sld xmlns:a="http://schemas.openxmlformats.org/drawingml/2006/main" xmlns:r="http://schemas.openxmlformats.org/officeDocument/2006/relationships" xmlns:p="http://schemas.openxmlformats.org/presentationml/2006/main">
   <p:cSld>
     <p:spTree>
       <p:nvGrpSpPr>
@@ -3348,7 +3352,14 @@
         <p:cNvGrpSpPr/>
         <p:nvPr/>
       </p:nvGrpSpPr>
-      <p:grpSpPr/>
+      <p:grpSpPr>
+        <a:xfrm>
+          <a:off x="0" y="0"/>
+          <a:ext cx="0" cy="0"/>
+          <a:chOff x="0" y="0"/>
+          <a:chExt cx="0" cy="0"/>
+        </a:xfrm>
+      </p:grpSpPr>
       <p:sp>
         <p:nvSpPr>
           <p:cNvPr id="2" name="Rectangle 1"/>
@@ -3390,6 +3401,7 @@
           <a:lstStyle/>
           <a:p>
             <a:pPr algn="ctr"/>
+            <a:endParaRPr/>
           </a:p>
         </p:txBody>
       </p:sp>
@@ -3476,6 +3488,7 @@
           <a:lstStyle/>
           <a:p>
             <a:pPr algn="ctr"/>
+            <a:endParaRPr/>
           </a:p>
         </p:txBody>
       </p:sp>
@@ -3536,15 +3549,45 @@
         <a:graphic>
           <a:graphicData uri="http://schemas.openxmlformats.org/drawingml/2006/table">
             <a:tbl>
-              <a:tblPr firstRow="0" bandRow="0">
+              <a:tblPr>
                 <a:tableStyleId>{2D5ABB26-0587-4C30-8999-92F81FD0307C}</a:tableStyleId>
               </a:tblPr>
               <a:tblGrid>
-                <a:gridCol w="1828800"/>
-                <a:gridCol w="2057400"/>
-                <a:gridCol w="2340864"/>
-                <a:gridCol w="2340864"/>
-                <a:gridCol w="2340864"/>
+                <a:gridCol w="1828800">
+                  <a:extLst>
+                    <a:ext uri="{9D8B030D-6E8A-4147-A177-3AD203B41FA5}">
+                      <a16:colId xmlns:a16="http://schemas.microsoft.com/office/drawing/2014/main" val="20000"/>
+                    </a:ext>
+                  </a:extLst>
+                </a:gridCol>
+                <a:gridCol w="2057400">
+                  <a:extLst>
+                    <a:ext uri="{9D8B030D-6E8A-4147-A177-3AD203B41FA5}">
+                      <a16:colId xmlns:a16="http://schemas.microsoft.com/office/drawing/2014/main" val="20001"/>
+                    </a:ext>
+                  </a:extLst>
+                </a:gridCol>
+                <a:gridCol w="2340864">
+                  <a:extLst>
+                    <a:ext uri="{9D8B030D-6E8A-4147-A177-3AD203B41FA5}">
+                      <a16:colId xmlns:a16="http://schemas.microsoft.com/office/drawing/2014/main" val="20002"/>
+                    </a:ext>
+                  </a:extLst>
+                </a:gridCol>
+                <a:gridCol w="2340864">
+                  <a:extLst>
+                    <a:ext uri="{9D8B030D-6E8A-4147-A177-3AD203B41FA5}">
+                      <a16:colId xmlns:a16="http://schemas.microsoft.com/office/drawing/2014/main" val="20003"/>
+                    </a:ext>
+                  </a:extLst>
+                </a:gridCol>
+                <a:gridCol w="2340864">
+                  <a:extLst>
+                    <a:ext uri="{9D8B030D-6E8A-4147-A177-3AD203B41FA5}">
+                      <a16:colId xmlns:a16="http://schemas.microsoft.com/office/drawing/2014/main" val="20004"/>
+                    </a:ext>
+                  </a:extLst>
+                </a:gridCol>
               </a:tblGrid>
               <a:tr h="457200">
                 <a:tc>
@@ -3564,7 +3607,7 @@
                       </a:r>
                     </a:p>
                   </a:txBody>
-                  <a:tcPr anchor="ctr" marL="127000" marR="76200" marT="25400" marB="25400">
+                  <a:tcPr marL="127000" marR="76200" marT="25400" marB="25400" anchor="ctr">
                     <a:noFill/>
                   </a:tcPr>
                 </a:tc>
@@ -3585,7 +3628,7 @@
                       </a:r>
                     </a:p>
                   </a:txBody>
-                  <a:tcPr anchor="ctr" marL="127000" marR="76200" marT="25400" marB="25400">
+                  <a:tcPr marL="127000" marR="76200" marT="25400" marB="25400" anchor="ctr">
                     <a:noFill/>
                   </a:tcPr>
                 </a:tc>
@@ -3606,7 +3649,7 @@
                       </a:r>
                     </a:p>
                   </a:txBody>
-                  <a:tcPr anchor="ctr" marL="127000" marR="76200" marT="25400" marB="25400">
+                  <a:tcPr marL="127000" marR="76200" marT="25400" marB="25400" anchor="ctr">
                     <a:noFill/>
                   </a:tcPr>
                 </a:tc>
@@ -3627,7 +3670,7 @@
                       </a:r>
                     </a:p>
                   </a:txBody>
-                  <a:tcPr anchor="ctr" marL="127000" marR="76200" marT="25400" marB="25400">
+                  <a:tcPr marL="127000" marR="76200" marT="25400" marB="25400" anchor="ctr">
                     <a:noFill/>
                   </a:tcPr>
                 </a:tc>
@@ -3648,10 +3691,15 @@
                       </a:r>
                     </a:p>
                   </a:txBody>
-                  <a:tcPr anchor="ctr" marL="127000" marR="76200" marT="25400" marB="25400">
+                  <a:tcPr marL="127000" marR="76200" marT="25400" marB="25400" anchor="ctr">
                     <a:noFill/>
                   </a:tcPr>
                 </a:tc>
+                <a:extLst>
+                  <a:ext uri="{0D108BD9-81ED-4DB2-BD59-A6C34878D82A}">
+                    <a16:rowId xmlns:a16="http://schemas.microsoft.com/office/drawing/2014/main" val="10000"/>
+                  </a:ext>
+                </a:extLst>
               </a:tr>
               <a:tr h="402336">
                 <a:tc>
@@ -3671,7 +3719,7 @@
                       </a:r>
                     </a:p>
                   </a:txBody>
-                  <a:tcPr anchor="ctr" marL="127000" marR="76200" marT="25400" marB="25400">
+                  <a:tcPr marL="127000" marR="76200" marT="25400" marB="25400" anchor="ctr">
                     <a:noFill/>
                   </a:tcPr>
                 </a:tc>
@@ -3692,7 +3740,7 @@
                       </a:r>
                     </a:p>
                   </a:txBody>
-                  <a:tcPr anchor="ctr" marL="127000" marR="76200" marT="25400" marB="25400">
+                  <a:tcPr marL="127000" marR="76200" marT="25400" marB="25400" anchor="ctr">
                     <a:noFill/>
                   </a:tcPr>
                 </a:tc>
@@ -3713,7 +3761,7 @@
                       </a:r>
                     </a:p>
                   </a:txBody>
-                  <a:tcPr anchor="ctr" marL="127000" marR="76200" marT="25400" marB="25400">
+                  <a:tcPr marL="127000" marR="76200" marT="25400" marB="25400" anchor="ctr">
                     <a:noFill/>
                   </a:tcPr>
                 </a:tc>
@@ -3734,7 +3782,7 @@
                       </a:r>
                     </a:p>
                   </a:txBody>
-                  <a:tcPr anchor="ctr" marL="127000" marR="76200" marT="25400" marB="25400">
+                  <a:tcPr marL="127000" marR="76200" marT="25400" marB="25400" anchor="ctr">
                     <a:noFill/>
                   </a:tcPr>
                 </a:tc>
@@ -3755,10 +3803,15 @@
                       </a:r>
                     </a:p>
                   </a:txBody>
-                  <a:tcPr anchor="ctr" marL="127000" marR="76200" marT="25400" marB="25400">
+                  <a:tcPr marL="127000" marR="76200" marT="25400" marB="25400" anchor="ctr">
                     <a:noFill/>
                   </a:tcPr>
                 </a:tc>
+                <a:extLst>
+                  <a:ext uri="{0D108BD9-81ED-4DB2-BD59-A6C34878D82A}">
+                    <a16:rowId xmlns:a16="http://schemas.microsoft.com/office/drawing/2014/main" val="10001"/>
+                  </a:ext>
+                </a:extLst>
               </a:tr>
               <a:tr h="402336">
                 <a:tc>
@@ -3778,7 +3831,7 @@
                       </a:r>
                     </a:p>
                   </a:txBody>
-                  <a:tcPr anchor="ctr" marL="127000" marR="76200" marT="25400" marB="25400">
+                  <a:tcPr marL="127000" marR="76200" marT="25400" marB="25400" anchor="ctr">
                     <a:noFill/>
                   </a:tcPr>
                 </a:tc>
@@ -3799,7 +3852,7 @@
                       </a:r>
                     </a:p>
                   </a:txBody>
-                  <a:tcPr anchor="ctr" marL="127000" marR="76200" marT="25400" marB="25400">
+                  <a:tcPr marL="127000" marR="76200" marT="25400" marB="25400" anchor="ctr">
                     <a:noFill/>
                   </a:tcPr>
                 </a:tc>
@@ -3820,7 +3873,7 @@
                       </a:r>
                     </a:p>
                   </a:txBody>
-                  <a:tcPr anchor="ctr" marL="127000" marR="76200" marT="25400" marB="25400">
+                  <a:tcPr marL="127000" marR="76200" marT="25400" marB="25400" anchor="ctr">
                     <a:noFill/>
                   </a:tcPr>
                 </a:tc>
@@ -3841,7 +3894,7 @@
                       </a:r>
                     </a:p>
                   </a:txBody>
-                  <a:tcPr anchor="ctr" marL="127000" marR="76200" marT="25400" marB="25400">
+                  <a:tcPr marL="127000" marR="76200" marT="25400" marB="25400" anchor="ctr">
                     <a:noFill/>
                   </a:tcPr>
                 </a:tc>
@@ -3862,10 +3915,15 @@
                       </a:r>
                     </a:p>
                   </a:txBody>
-                  <a:tcPr anchor="ctr" marL="127000" marR="76200" marT="25400" marB="25400">
+                  <a:tcPr marL="127000" marR="76200" marT="25400" marB="25400" anchor="ctr">
                     <a:noFill/>
                   </a:tcPr>
                 </a:tc>
+                <a:extLst>
+                  <a:ext uri="{0D108BD9-81ED-4DB2-BD59-A6C34878D82A}">
+                    <a16:rowId xmlns:a16="http://schemas.microsoft.com/office/drawing/2014/main" val="10002"/>
+                  </a:ext>
+                </a:extLst>
               </a:tr>
               <a:tr h="402336">
                 <a:tc>
@@ -3885,7 +3943,7 @@
                       </a:r>
                     </a:p>
                   </a:txBody>
-                  <a:tcPr anchor="ctr" marL="127000" marR="76200" marT="25400" marB="25400">
+                  <a:tcPr marL="127000" marR="76200" marT="25400" marB="25400" anchor="ctr">
                     <a:noFill/>
                   </a:tcPr>
                 </a:tc>
@@ -3906,7 +3964,7 @@
                       </a:r>
                     </a:p>
                   </a:txBody>
-                  <a:tcPr anchor="ctr" marL="127000" marR="76200" marT="25400" marB="25400">
+                  <a:tcPr marL="127000" marR="76200" marT="25400" marB="25400" anchor="ctr">
                     <a:noFill/>
                   </a:tcPr>
                 </a:tc>
@@ -3927,7 +3985,7 @@
                       </a:r>
                     </a:p>
                   </a:txBody>
-                  <a:tcPr anchor="ctr" marL="127000" marR="76200" marT="25400" marB="25400">
+                  <a:tcPr marL="127000" marR="76200" marT="25400" marB="25400" anchor="ctr">
                     <a:noFill/>
                   </a:tcPr>
                 </a:tc>
@@ -3948,7 +4006,7 @@
                       </a:r>
                     </a:p>
                   </a:txBody>
-                  <a:tcPr anchor="ctr" marL="127000" marR="76200" marT="25400" marB="25400">
+                  <a:tcPr marL="127000" marR="76200" marT="25400" marB="25400" anchor="ctr">
                     <a:noFill/>
                   </a:tcPr>
                 </a:tc>
@@ -3969,10 +4027,15 @@
                       </a:r>
                     </a:p>
                   </a:txBody>
-                  <a:tcPr anchor="ctr" marL="127000" marR="76200" marT="25400" marB="25400">
+                  <a:tcPr marL="127000" marR="76200" marT="25400" marB="25400" anchor="ctr">
                     <a:noFill/>
                   </a:tcPr>
                 </a:tc>
+                <a:extLst>
+                  <a:ext uri="{0D108BD9-81ED-4DB2-BD59-A6C34878D82A}">
+                    <a16:rowId xmlns:a16="http://schemas.microsoft.com/office/drawing/2014/main" val="10003"/>
+                  </a:ext>
+                </a:extLst>
               </a:tr>
               <a:tr h="402336">
                 <a:tc>
@@ -3992,7 +4055,7 @@
                       </a:r>
                     </a:p>
                   </a:txBody>
-                  <a:tcPr anchor="ctr" marL="127000" marR="76200" marT="25400" marB="25400">
+                  <a:tcPr marL="127000" marR="76200" marT="25400" marB="25400" anchor="ctr">
                     <a:noFill/>
                   </a:tcPr>
                 </a:tc>
@@ -4013,7 +4076,7 @@
                       </a:r>
                     </a:p>
                   </a:txBody>
-                  <a:tcPr anchor="ctr" marL="127000" marR="76200" marT="25400" marB="25400">
+                  <a:tcPr marL="127000" marR="76200" marT="25400" marB="25400" anchor="ctr">
                     <a:noFill/>
                   </a:tcPr>
                 </a:tc>
@@ -4034,7 +4097,7 @@
                       </a:r>
                     </a:p>
                   </a:txBody>
-                  <a:tcPr anchor="ctr" marL="127000" marR="76200" marT="25400" marB="25400">
+                  <a:tcPr marL="127000" marR="76200" marT="25400" marB="25400" anchor="ctr">
                     <a:noFill/>
                   </a:tcPr>
                 </a:tc>
@@ -4055,7 +4118,7 @@
                       </a:r>
                     </a:p>
                   </a:txBody>
-                  <a:tcPr anchor="ctr" marL="127000" marR="76200" marT="25400" marB="25400">
+                  <a:tcPr marL="127000" marR="76200" marT="25400" marB="25400" anchor="ctr">
                     <a:noFill/>
                   </a:tcPr>
                 </a:tc>
@@ -4076,10 +4139,15 @@
                       </a:r>
                     </a:p>
                   </a:txBody>
-                  <a:tcPr anchor="ctr" marL="127000" marR="76200" marT="25400" marB="25400">
+                  <a:tcPr marL="127000" marR="76200" marT="25400" marB="25400" anchor="ctr">
                     <a:noFill/>
                   </a:tcPr>
                 </a:tc>
+                <a:extLst>
+                  <a:ext uri="{0D108BD9-81ED-4DB2-BD59-A6C34878D82A}">
+                    <a16:rowId xmlns:a16="http://schemas.microsoft.com/office/drawing/2014/main" val="10004"/>
+                  </a:ext>
+                </a:extLst>
               </a:tr>
               <a:tr h="402336">
                 <a:tc>
@@ -4099,7 +4167,7 @@
                       </a:r>
                     </a:p>
                   </a:txBody>
-                  <a:tcPr anchor="ctr" marL="127000" marR="76200" marT="25400" marB="25400">
+                  <a:tcPr marL="127000" marR="76200" marT="25400" marB="25400" anchor="ctr">
                     <a:noFill/>
                   </a:tcPr>
                 </a:tc>
@@ -4120,7 +4188,7 @@
                       </a:r>
                     </a:p>
                   </a:txBody>
-                  <a:tcPr anchor="ctr" marL="127000" marR="76200" marT="25400" marB="25400">
+                  <a:tcPr marL="127000" marR="76200" marT="25400" marB="25400" anchor="ctr">
                     <a:noFill/>
                   </a:tcPr>
                 </a:tc>
@@ -4141,7 +4209,7 @@
                       </a:r>
                     </a:p>
                   </a:txBody>
-                  <a:tcPr anchor="ctr" marL="127000" marR="76200" marT="25400" marB="25400">
+                  <a:tcPr marL="127000" marR="76200" marT="25400" marB="25400" anchor="ctr">
                     <a:noFill/>
                   </a:tcPr>
                 </a:tc>
@@ -4162,7 +4230,7 @@
                       </a:r>
                     </a:p>
                   </a:txBody>
-                  <a:tcPr anchor="ctr" marL="127000" marR="76200" marT="25400" marB="25400">
+                  <a:tcPr marL="127000" marR="76200" marT="25400" marB="25400" anchor="ctr">
                     <a:noFill/>
                   </a:tcPr>
                 </a:tc>
@@ -4183,10 +4251,15 @@
                       </a:r>
                     </a:p>
                   </a:txBody>
-                  <a:tcPr anchor="ctr" marL="127000" marR="76200" marT="25400" marB="25400">
+                  <a:tcPr marL="127000" marR="76200" marT="25400" marB="25400" anchor="ctr">
                     <a:noFill/>
                   </a:tcPr>
                 </a:tc>
+                <a:extLst>
+                  <a:ext uri="{0D108BD9-81ED-4DB2-BD59-A6C34878D82A}">
+                    <a16:rowId xmlns:a16="http://schemas.microsoft.com/office/drawing/2014/main" val="10005"/>
+                  </a:ext>
+                </a:extLst>
               </a:tr>
               <a:tr h="402336">
                 <a:tc>
@@ -4206,7 +4279,7 @@
                       </a:r>
                     </a:p>
                   </a:txBody>
-                  <a:tcPr anchor="ctr" marL="127000" marR="76200" marT="25400" marB="25400">
+                  <a:tcPr marL="127000" marR="76200" marT="25400" marB="25400" anchor="ctr">
                     <a:noFill/>
                   </a:tcPr>
                 </a:tc>
@@ -4227,7 +4300,7 @@
                       </a:r>
                     </a:p>
                   </a:txBody>
-                  <a:tcPr anchor="ctr" marL="127000" marR="76200" marT="25400" marB="25400">
+                  <a:tcPr marL="127000" marR="76200" marT="25400" marB="25400" anchor="ctr">
                     <a:noFill/>
                   </a:tcPr>
                 </a:tc>
@@ -4248,7 +4321,7 @@
                       </a:r>
                     </a:p>
                   </a:txBody>
-                  <a:tcPr anchor="ctr" marL="127000" marR="76200" marT="25400" marB="25400">
+                  <a:tcPr marL="127000" marR="76200" marT="25400" marB="25400" anchor="ctr">
                     <a:noFill/>
                   </a:tcPr>
                 </a:tc>
@@ -4269,7 +4342,7 @@
                       </a:r>
                     </a:p>
                   </a:txBody>
-                  <a:tcPr anchor="ctr" marL="127000" marR="76200" marT="25400" marB="25400">
+                  <a:tcPr marL="127000" marR="76200" marT="25400" marB="25400" anchor="ctr">
                     <a:noFill/>
                   </a:tcPr>
                 </a:tc>
@@ -4290,10 +4363,15 @@
                       </a:r>
                     </a:p>
                   </a:txBody>
-                  <a:tcPr anchor="ctr" marL="127000" marR="76200" marT="25400" marB="25400">
+                  <a:tcPr marL="127000" marR="76200" marT="25400" marB="25400" anchor="ctr">
                     <a:noFill/>
                   </a:tcPr>
                 </a:tc>
+                <a:extLst>
+                  <a:ext uri="{0D108BD9-81ED-4DB2-BD59-A6C34878D82A}">
+                    <a16:rowId xmlns:a16="http://schemas.microsoft.com/office/drawing/2014/main" val="10006"/>
+                  </a:ext>
+                </a:extLst>
               </a:tr>
               <a:tr h="402336">
                 <a:tc>
@@ -4313,7 +4391,7 @@
                       </a:r>
                     </a:p>
                   </a:txBody>
-                  <a:tcPr anchor="ctr" marL="127000" marR="76200" marT="25400" marB="25400">
+                  <a:tcPr marL="127000" marR="76200" marT="25400" marB="25400" anchor="ctr">
                     <a:noFill/>
                   </a:tcPr>
                 </a:tc>
@@ -4334,7 +4412,7 @@
                       </a:r>
                     </a:p>
                   </a:txBody>
-                  <a:tcPr anchor="ctr" marL="127000" marR="76200" marT="25400" marB="25400">
+                  <a:tcPr marL="127000" marR="76200" marT="25400" marB="25400" anchor="ctr">
                     <a:noFill/>
                   </a:tcPr>
                 </a:tc>
@@ -4355,7 +4433,7 @@
                       </a:r>
                     </a:p>
                   </a:txBody>
-                  <a:tcPr anchor="ctr" marL="127000" marR="76200" marT="25400" marB="25400">
+                  <a:tcPr marL="127000" marR="76200" marT="25400" marB="25400" anchor="ctr">
                     <a:noFill/>
                   </a:tcPr>
                 </a:tc>
@@ -4376,7 +4454,7 @@
                       </a:r>
                     </a:p>
                   </a:txBody>
-                  <a:tcPr anchor="ctr" marL="127000" marR="76200" marT="25400" marB="25400">
+                  <a:tcPr marL="127000" marR="76200" marT="25400" marB="25400" anchor="ctr">
                     <a:noFill/>
                   </a:tcPr>
                 </a:tc>
@@ -4397,10 +4475,15 @@
                       </a:r>
                     </a:p>
                   </a:txBody>
-                  <a:tcPr anchor="ctr" marL="127000" marR="76200" marT="25400" marB="25400">
+                  <a:tcPr marL="127000" marR="76200" marT="25400" marB="25400" anchor="ctr">
                     <a:noFill/>
                   </a:tcPr>
                 </a:tc>
+                <a:extLst>
+                  <a:ext uri="{0D108BD9-81ED-4DB2-BD59-A6C34878D82A}">
+                    <a16:rowId xmlns:a16="http://schemas.microsoft.com/office/drawing/2014/main" val="10007"/>
+                  </a:ext>
+                </a:extLst>
               </a:tr>
               <a:tr h="402336">
                 <a:tc>
@@ -4420,7 +4503,7 @@
                       </a:r>
                     </a:p>
                   </a:txBody>
-                  <a:tcPr anchor="ctr" marL="127000" marR="76200" marT="25400" marB="25400">
+                  <a:tcPr marL="127000" marR="76200" marT="25400" marB="25400" anchor="ctr">
                     <a:noFill/>
                   </a:tcPr>
                 </a:tc>
@@ -4430,18 +4513,10 @@
                     <a:lstStyle/>
                     <a:p>
                       <a:pPr algn="ctr"/>
-                      <a:r>
-                        <a:rPr sz="1400" b="1">
-                          <a:solidFill>
-                            <a:srgbClr val="111111"/>
-                          </a:solidFill>
-                          <a:latin typeface="Times New Roman"/>
-                        </a:rPr>
-                        <a:t/>
-                      </a:r>
+                      <a:endParaRPr/>
                     </a:p>
                   </a:txBody>
-                  <a:tcPr anchor="ctr" marL="127000" marR="76200" marT="25400" marB="25400">
+                  <a:tcPr marL="127000" marR="76200" marT="25400" marB="25400" anchor="ctr">
                     <a:noFill/>
                   </a:tcPr>
                 </a:tc>
@@ -4462,7 +4537,7 @@
                       </a:r>
                     </a:p>
                   </a:txBody>
-                  <a:tcPr anchor="ctr" marL="127000" marR="76200" marT="25400" marB="25400">
+                  <a:tcPr marL="127000" marR="76200" marT="25400" marB="25400" anchor="ctr">
                     <a:noFill/>
                   </a:tcPr>
                 </a:tc>
@@ -4483,7 +4558,7 @@
                       </a:r>
                     </a:p>
                   </a:txBody>
-                  <a:tcPr anchor="ctr" marL="127000" marR="76200" marT="25400" marB="25400">
+                  <a:tcPr marL="127000" marR="76200" marT="25400" marB="25400" anchor="ctr">
                     <a:noFill/>
                   </a:tcPr>
                 </a:tc>
@@ -4504,10 +4579,15 @@
                       </a:r>
                     </a:p>
                   </a:txBody>
-                  <a:tcPr anchor="ctr" marL="127000" marR="76200" marT="25400" marB="25400">
+                  <a:tcPr marL="127000" marR="76200" marT="25400" marB="25400" anchor="ctr">
                     <a:noFill/>
                   </a:tcPr>
                 </a:tc>
+                <a:extLst>
+                  <a:ext uri="{0D108BD9-81ED-4DB2-BD59-A6C34878D82A}">
+                    <a16:rowId xmlns:a16="http://schemas.microsoft.com/office/drawing/2014/main" val="10008"/>
+                  </a:ext>
+                </a:extLst>
               </a:tr>
             </a:tbl>
           </a:graphicData>
@@ -4554,6 +4634,7 @@
           <a:lstStyle/>
           <a:p>
             <a:pPr algn="ctr"/>
+            <a:endParaRPr/>
           </a:p>
         </p:txBody>
       </p:sp>
@@ -4598,6 +4679,7 @@
           <a:lstStyle/>
           <a:p>
             <a:pPr algn="ctr"/>
+            <a:endParaRPr/>
           </a:p>
         </p:txBody>
       </p:sp>
@@ -4642,6 +4724,7 @@
           <a:lstStyle/>
           <a:p>
             <a:pPr algn="ctr"/>
+            <a:endParaRPr/>
           </a:p>
         </p:txBody>
       </p:sp>
@@ -4686,6 +4769,7 @@
           <a:lstStyle/>
           <a:p>
             <a:pPr algn="ctr"/>
+            <a:endParaRPr/>
           </a:p>
         </p:txBody>
       </p:sp>
@@ -4777,7 +4861,7 @@
 </file>
 
 <file path=ppt/slides/slide11.xml><?xml version="1.0" encoding="utf-8"?>
-<p:sld xmlns:a="http://schemas.openxmlformats.org/drawingml/2006/main" xmlns:p="http://schemas.openxmlformats.org/presentationml/2006/main" xmlns:r="http://schemas.openxmlformats.org/officeDocument/2006/relationships">
+<p:sld xmlns:a="http://schemas.openxmlformats.org/drawingml/2006/main" xmlns:r="http://schemas.openxmlformats.org/officeDocument/2006/relationships" xmlns:p="http://schemas.openxmlformats.org/presentationml/2006/main">
   <p:cSld>
     <p:spTree>
       <p:nvGrpSpPr>
@@ -4785,7 +4869,14 @@
         <p:cNvGrpSpPr/>
         <p:nvPr/>
       </p:nvGrpSpPr>
-      <p:grpSpPr/>
+      <p:grpSpPr>
+        <a:xfrm>
+          <a:off x="0" y="0"/>
+          <a:ext cx="0" cy="0"/>
+          <a:chOff x="0" y="0"/>
+          <a:chExt cx="0" cy="0"/>
+        </a:xfrm>
+      </p:grpSpPr>
       <p:sp>
         <p:nvSpPr>
           <p:cNvPr id="2" name="Rectangle 1"/>
@@ -4827,6 +4918,7 @@
           <a:lstStyle/>
           <a:p>
             <a:pPr algn="ctr"/>
+            <a:endParaRPr/>
           </a:p>
         </p:txBody>
       </p:sp>
@@ -4913,6 +5005,7 @@
           <a:lstStyle/>
           <a:p>
             <a:pPr algn="ctr"/>
+            <a:endParaRPr/>
           </a:p>
         </p:txBody>
       </p:sp>
@@ -5377,7 +5470,7 @@
 </file>
 
 <file path=ppt/slides/slide2.xml><?xml version="1.0" encoding="utf-8"?>
-<p:sld xmlns:a="http://schemas.openxmlformats.org/drawingml/2006/main" xmlns:p="http://schemas.openxmlformats.org/presentationml/2006/main" xmlns:r="http://schemas.openxmlformats.org/officeDocument/2006/relationships">
+<p:sld xmlns:a="http://schemas.openxmlformats.org/drawingml/2006/main" xmlns:r="http://schemas.openxmlformats.org/officeDocument/2006/relationships" xmlns:p="http://schemas.openxmlformats.org/presentationml/2006/main">
   <p:cSld>
     <p:spTree>
       <p:nvGrpSpPr>
@@ -5385,7 +5478,14 @@
         <p:cNvGrpSpPr/>
         <p:nvPr/>
       </p:nvGrpSpPr>
-      <p:grpSpPr/>
+      <p:grpSpPr>
+        <a:xfrm>
+          <a:off x="0" y="0"/>
+          <a:ext cx="0" cy="0"/>
+          <a:chOff x="0" y="0"/>
+          <a:chExt cx="0" cy="0"/>
+        </a:xfrm>
+      </p:grpSpPr>
       <p:sp>
         <p:nvSpPr>
           <p:cNvPr id="2" name="Rectangle 1"/>
@@ -5427,6 +5527,7 @@
           <a:lstStyle/>
           <a:p>
             <a:pPr algn="ctr"/>
+            <a:endParaRPr/>
           </a:p>
         </p:txBody>
       </p:sp>
@@ -5513,6 +5614,7 @@
           <a:lstStyle/>
           <a:p>
             <a:pPr algn="ctr"/>
+            <a:endParaRPr/>
           </a:p>
         </p:txBody>
       </p:sp>
@@ -5597,7 +5699,7 @@
           </a:fontRef>
         </p:style>
         <p:txBody>
-          <a:bodyPr rtlCol="0" anchor="ctr" wrap="square" lIns="228600"/>
+          <a:bodyPr wrap="square" lIns="228600" rtlCol="0" anchor="ctr"/>
           <a:lstStyle/>
           <a:p>
             <a:pPr algn="l">
@@ -5680,7 +5782,7 @@
 </file>
 
 <file path=ppt/slides/slide3.xml><?xml version="1.0" encoding="utf-8"?>
-<p:sld xmlns:a="http://schemas.openxmlformats.org/drawingml/2006/main" xmlns:p="http://schemas.openxmlformats.org/presentationml/2006/main" xmlns:r="http://schemas.openxmlformats.org/officeDocument/2006/relationships">
+<p:sld xmlns:a="http://schemas.openxmlformats.org/drawingml/2006/main" xmlns:r="http://schemas.openxmlformats.org/officeDocument/2006/relationships" xmlns:p="http://schemas.openxmlformats.org/presentationml/2006/main">
   <p:cSld>
     <p:spTree>
       <p:nvGrpSpPr>
@@ -5688,7 +5790,14 @@
         <p:cNvGrpSpPr/>
         <p:nvPr/>
       </p:nvGrpSpPr>
-      <p:grpSpPr/>
+      <p:grpSpPr>
+        <a:xfrm>
+          <a:off x="0" y="0"/>
+          <a:ext cx="0" cy="0"/>
+          <a:chOff x="0" y="0"/>
+          <a:chExt cx="0" cy="0"/>
+        </a:xfrm>
+      </p:grpSpPr>
       <p:sp>
         <p:nvSpPr>
           <p:cNvPr id="2" name="Rectangle 1"/>
@@ -5730,6 +5839,7 @@
           <a:lstStyle/>
           <a:p>
             <a:pPr algn="ctr"/>
+            <a:endParaRPr/>
           </a:p>
         </p:txBody>
       </p:sp>
@@ -5816,6 +5926,7 @@
           <a:lstStyle/>
           <a:p>
             <a:pPr algn="ctr"/>
+            <a:endParaRPr/>
           </a:p>
         </p:txBody>
       </p:sp>
@@ -5858,7 +5969,7 @@
           </a:fontRef>
         </p:style>
         <p:txBody>
-          <a:bodyPr rtlCol="0" anchor="t" wrap="square" lIns="203200" rIns="203200" tIns="228600"/>
+          <a:bodyPr wrap="square" lIns="203200" tIns="228600" rIns="203200" rtlCol="0" anchor="t"/>
           <a:lstStyle/>
           <a:p>
             <a:pPr algn="l">
@@ -5958,7 +6069,7 @@
           </a:fontRef>
         </p:style>
         <p:txBody>
-          <a:bodyPr rtlCol="0" anchor="t" wrap="square" lIns="203200" rIns="203200" tIns="228600"/>
+          <a:bodyPr wrap="square" lIns="203200" tIns="228600" rIns="203200" rtlCol="0" anchor="t"/>
           <a:lstStyle/>
           <a:p>
             <a:pPr algn="l">
@@ -6058,7 +6169,7 @@
           </a:fontRef>
         </p:style>
         <p:txBody>
-          <a:bodyPr rtlCol="0" anchor="t" wrap="square" lIns="203200" rIns="203200" tIns="228600"/>
+          <a:bodyPr wrap="square" lIns="203200" tIns="228600" rIns="203200" rtlCol="0" anchor="t"/>
           <a:lstStyle/>
           <a:p>
             <a:pPr algn="l">
@@ -6128,7 +6239,7 @@
 </file>
 
 <file path=ppt/slides/slide4.xml><?xml version="1.0" encoding="utf-8"?>
-<p:sld xmlns:a="http://schemas.openxmlformats.org/drawingml/2006/main" xmlns:p="http://schemas.openxmlformats.org/presentationml/2006/main" xmlns:r="http://schemas.openxmlformats.org/officeDocument/2006/relationships">
+<p:sld xmlns:a="http://schemas.openxmlformats.org/drawingml/2006/main" xmlns:r="http://schemas.openxmlformats.org/officeDocument/2006/relationships" xmlns:p="http://schemas.openxmlformats.org/presentationml/2006/main">
   <p:cSld>
     <p:spTree>
       <p:nvGrpSpPr>
@@ -6136,7 +6247,14 @@
         <p:cNvGrpSpPr/>
         <p:nvPr/>
       </p:nvGrpSpPr>
-      <p:grpSpPr/>
+      <p:grpSpPr>
+        <a:xfrm>
+          <a:off x="0" y="0"/>
+          <a:ext cx="0" cy="0"/>
+          <a:chOff x="0" y="0"/>
+          <a:chExt cx="0" cy="0"/>
+        </a:xfrm>
+      </p:grpSpPr>
       <p:sp>
         <p:nvSpPr>
           <p:cNvPr id="2" name="Rectangle 1"/>
@@ -6178,6 +6296,7 @@
           <a:lstStyle/>
           <a:p>
             <a:pPr algn="ctr"/>
+            <a:endParaRPr/>
           </a:p>
         </p:txBody>
       </p:sp>
@@ -6264,6 +6383,7 @@
           <a:lstStyle/>
           <a:p>
             <a:pPr algn="ctr"/>
+            <a:endParaRPr/>
           </a:p>
         </p:txBody>
       </p:sp>
@@ -6696,7 +6816,7 @@
 </file>
 
 <file path=ppt/slides/slide5.xml><?xml version="1.0" encoding="utf-8"?>
-<p:sld xmlns:a="http://schemas.openxmlformats.org/drawingml/2006/main" xmlns:p="http://schemas.openxmlformats.org/presentationml/2006/main" xmlns:r="http://schemas.openxmlformats.org/officeDocument/2006/relationships">
+<p:sld xmlns:a="http://schemas.openxmlformats.org/drawingml/2006/main" xmlns:r="http://schemas.openxmlformats.org/officeDocument/2006/relationships" xmlns:p="http://schemas.openxmlformats.org/presentationml/2006/main">
   <p:cSld>
     <p:spTree>
       <p:nvGrpSpPr>
@@ -6704,7 +6824,14 @@
         <p:cNvGrpSpPr/>
         <p:nvPr/>
       </p:nvGrpSpPr>
-      <p:grpSpPr/>
+      <p:grpSpPr>
+        <a:xfrm>
+          <a:off x="0" y="0"/>
+          <a:ext cx="0" cy="0"/>
+          <a:chOff x="0" y="0"/>
+          <a:chExt cx="0" cy="0"/>
+        </a:xfrm>
+      </p:grpSpPr>
       <p:sp>
         <p:nvSpPr>
           <p:cNvPr id="2" name="Rectangle 1"/>
@@ -6746,6 +6873,7 @@
           <a:lstStyle/>
           <a:p>
             <a:pPr algn="ctr"/>
+            <a:endParaRPr/>
           </a:p>
         </p:txBody>
       </p:sp>
@@ -6832,6 +6960,7 @@
           <a:lstStyle/>
           <a:p>
             <a:pPr algn="ctr"/>
+            <a:endParaRPr/>
           </a:p>
         </p:txBody>
       </p:sp>
@@ -6874,7 +7003,7 @@
           </a:fontRef>
         </p:style>
         <p:txBody>
-          <a:bodyPr rtlCol="0" anchor="t" wrap="square" lIns="139700" rIns="114300" tIns="165100"/>
+          <a:bodyPr wrap="square" lIns="139700" tIns="165100" rIns="114300" rtlCol="0" anchor="t"/>
           <a:lstStyle/>
           <a:p>
             <a:pPr algn="l">
@@ -7012,7 +7141,7 @@
           </a:fontRef>
         </p:style>
         <p:txBody>
-          <a:bodyPr rtlCol="0" anchor="t" wrap="square" lIns="139700" rIns="114300" tIns="165100"/>
+          <a:bodyPr wrap="square" lIns="139700" tIns="165100" rIns="114300" rtlCol="0" anchor="t"/>
           <a:lstStyle/>
           <a:p>
             <a:pPr algn="l">
@@ -7131,7 +7260,7 @@
           </a:fontRef>
         </p:style>
         <p:txBody>
-          <a:bodyPr rtlCol="0" anchor="t" wrap="square" lIns="139700" rIns="114300" tIns="165100"/>
+          <a:bodyPr wrap="square" lIns="139700" tIns="165100" rIns="114300" rtlCol="0" anchor="t"/>
           <a:lstStyle/>
           <a:p>
             <a:pPr algn="l">
@@ -7250,7 +7379,7 @@
           </a:fontRef>
         </p:style>
         <p:txBody>
-          <a:bodyPr rtlCol="0" anchor="t" wrap="square" lIns="139700" rIns="114300" tIns="165100"/>
+          <a:bodyPr wrap="square" lIns="139700" tIns="165100" rIns="114300" rtlCol="0" anchor="t"/>
           <a:lstStyle/>
           <a:p>
             <a:pPr algn="l">
@@ -7369,7 +7498,7 @@
           </a:fontRef>
         </p:style>
         <p:txBody>
-          <a:bodyPr rtlCol="0" anchor="ctr" wrap="square" lIns="254000" rIns="254000"/>
+          <a:bodyPr wrap="square" lIns="254000" rIns="254000" rtlCol="0" anchor="ctr"/>
           <a:lstStyle/>
           <a:p>
             <a:pPr algn="l">
@@ -7462,7 +7591,7 @@
 </file>
 
 <file path=ppt/slides/slide6.xml><?xml version="1.0" encoding="utf-8"?>
-<p:sld xmlns:a="http://schemas.openxmlformats.org/drawingml/2006/main" xmlns:p="http://schemas.openxmlformats.org/presentationml/2006/main" xmlns:r="http://schemas.openxmlformats.org/officeDocument/2006/relationships">
+<p:sld xmlns:a="http://schemas.openxmlformats.org/drawingml/2006/main" xmlns:r="http://schemas.openxmlformats.org/officeDocument/2006/relationships" xmlns:p="http://schemas.openxmlformats.org/presentationml/2006/main">
   <p:cSld>
     <p:spTree>
       <p:nvGrpSpPr>
@@ -7470,7 +7599,14 @@
         <p:cNvGrpSpPr/>
         <p:nvPr/>
       </p:nvGrpSpPr>
-      <p:grpSpPr/>
+      <p:grpSpPr>
+        <a:xfrm>
+          <a:off x="0" y="0"/>
+          <a:ext cx="0" cy="0"/>
+          <a:chOff x="0" y="0"/>
+          <a:chExt cx="0" cy="0"/>
+        </a:xfrm>
+      </p:grpSpPr>
       <p:sp>
         <p:nvSpPr>
           <p:cNvPr id="2" name="Rectangle 1"/>
@@ -7512,6 +7648,7 @@
           <a:lstStyle/>
           <a:p>
             <a:pPr algn="ctr"/>
+            <a:endParaRPr/>
           </a:p>
         </p:txBody>
       </p:sp>
@@ -7598,6 +7735,7 @@
           <a:lstStyle/>
           <a:p>
             <a:pPr algn="ctr"/>
+            <a:endParaRPr/>
           </a:p>
         </p:txBody>
       </p:sp>
@@ -7685,7 +7823,7 @@
 </file>
 
 <file path=ppt/slides/slide7.xml><?xml version="1.0" encoding="utf-8"?>
-<p:sld xmlns:a="http://schemas.openxmlformats.org/drawingml/2006/main" xmlns:p="http://schemas.openxmlformats.org/presentationml/2006/main" xmlns:r="http://schemas.openxmlformats.org/officeDocument/2006/relationships">
+<p:sld xmlns:a="http://schemas.openxmlformats.org/drawingml/2006/main" xmlns:r="http://schemas.openxmlformats.org/officeDocument/2006/relationships" xmlns:p="http://schemas.openxmlformats.org/presentationml/2006/main">
   <p:cSld>
     <p:spTree>
       <p:nvGrpSpPr>
@@ -7693,7 +7831,14 @@
         <p:cNvGrpSpPr/>
         <p:nvPr/>
       </p:nvGrpSpPr>
-      <p:grpSpPr/>
+      <p:grpSpPr>
+        <a:xfrm>
+          <a:off x="0" y="0"/>
+          <a:ext cx="0" cy="0"/>
+          <a:chOff x="0" y="0"/>
+          <a:chExt cx="0" cy="0"/>
+        </a:xfrm>
+      </p:grpSpPr>
       <p:sp>
         <p:nvSpPr>
           <p:cNvPr id="2" name="Rectangle 1"/>
@@ -7735,6 +7880,7 @@
           <a:lstStyle/>
           <a:p>
             <a:pPr algn="ctr"/>
+            <a:endParaRPr/>
           </a:p>
         </p:txBody>
       </p:sp>
@@ -7821,6 +7967,7 @@
           <a:lstStyle/>
           <a:p>
             <a:pPr algn="ctr"/>
+            <a:endParaRPr/>
           </a:p>
         </p:txBody>
       </p:sp>
@@ -7861,16 +8008,7 @@
                 </a:solidFill>
                 <a:latin typeface="Times New Roman"/>
               </a:rPr>
-              <a:t>•  </a:t>
-            </a:r>
-            <a:r>
-              <a:rPr sz="1900" b="1" i="0">
-                <a:solidFill>
-                  <a:srgbClr val="111111"/>
-                </a:solidFill>
-                <a:latin typeface="Times New Roman"/>
-              </a:rPr>
-              <a:t>Record movement alongside EEG:</a:t>
+              <a:t>•  Record movement alongside EEG:</a:t>
             </a:r>
             <a:r>
               <a:rPr sz="1900" b="0" i="0">
@@ -7898,16 +8036,7 @@
                 </a:solidFill>
                 <a:latin typeface="Times New Roman"/>
               </a:rPr>
-              <a:t>•  </a:t>
-            </a:r>
-            <a:r>
-              <a:rPr sz="1900" b="1" i="0">
-                <a:solidFill>
-                  <a:srgbClr val="111111"/>
-                </a:solidFill>
-                <a:latin typeface="Times New Roman"/>
-              </a:rPr>
-              <a:t>Adversarial disentanglement (MID):</a:t>
+              <a:t>•  Adversarial disentanglement (MID):</a:t>
             </a:r>
             <a:r>
               <a:rPr sz="1900" b="0" i="0">
@@ -7935,16 +8064,7 @@
                 </a:solidFill>
                 <a:latin typeface="Times New Roman"/>
               </a:rPr>
-              <a:t>•  </a:t>
-            </a:r>
-            <a:r>
-              <a:rPr sz="1900" b="1" i="0">
-                <a:solidFill>
-                  <a:srgbClr val="111111"/>
-                </a:solidFill>
-                <a:latin typeface="Times New Roman"/>
-              </a:rPr>
-              <a:t>Decide from the invariant part only:</a:t>
+              <a:t>•  Decide from the invariant part only:</a:t>
             </a:r>
             <a:r>
               <a:rPr sz="1900" b="0" i="0">
@@ -7972,16 +8092,7 @@
                 </a:solidFill>
                 <a:latin typeface="Times New Roman"/>
               </a:rPr>
-              <a:t>•  </a:t>
-            </a:r>
-            <a:r>
-              <a:rPr sz="1900" b="1" i="0">
-                <a:solidFill>
-                  <a:srgbClr val="111111"/>
-                </a:solidFill>
-                <a:latin typeface="Times New Roman"/>
-              </a:rPr>
-              <a:t>Add honesty and safety:</a:t>
+              <a:t>•  Add honesty and safety:</a:t>
             </a:r>
             <a:r>
               <a:rPr sz="1900" b="0" i="0">
@@ -8034,7 +8145,7 @@
           </a:fontRef>
         </p:style>
         <p:txBody>
-          <a:bodyPr rtlCol="0" anchor="ctr" wrap="square" lIns="228600" rIns="228600"/>
+          <a:bodyPr wrap="square" lIns="228600" rIns="228600" rtlCol="0" anchor="ctr"/>
           <a:lstStyle/>
           <a:p>
             <a:pPr algn="l">
@@ -8075,7 +8186,7 @@
 </file>
 
 <file path=ppt/slides/slide8.xml><?xml version="1.0" encoding="utf-8"?>
-<p:sld xmlns:a="http://schemas.openxmlformats.org/drawingml/2006/main" xmlns:p="http://schemas.openxmlformats.org/presentationml/2006/main" xmlns:r="http://schemas.openxmlformats.org/officeDocument/2006/relationships">
+<p:sld xmlns:a="http://schemas.openxmlformats.org/drawingml/2006/main" xmlns:r="http://schemas.openxmlformats.org/officeDocument/2006/relationships" xmlns:p="http://schemas.openxmlformats.org/presentationml/2006/main">
   <p:cSld>
     <p:spTree>
       <p:nvGrpSpPr>
@@ -8083,7 +8194,14 @@
         <p:cNvGrpSpPr/>
         <p:nvPr/>
       </p:nvGrpSpPr>
-      <p:grpSpPr/>
+      <p:grpSpPr>
+        <a:xfrm>
+          <a:off x="0" y="0"/>
+          <a:ext cx="0" cy="0"/>
+          <a:chOff x="0" y="0"/>
+          <a:chExt cx="0" cy="0"/>
+        </a:xfrm>
+      </p:grpSpPr>
       <p:sp>
         <p:nvSpPr>
           <p:cNvPr id="2" name="Rectangle 1"/>
@@ -8125,6 +8243,7 @@
           <a:lstStyle/>
           <a:p>
             <a:pPr algn="ctr"/>
+            <a:endParaRPr/>
           </a:p>
         </p:txBody>
       </p:sp>
@@ -8211,6 +8330,7 @@
           <a:lstStyle/>
           <a:p>
             <a:pPr algn="ctr"/>
+            <a:endParaRPr/>
           </a:p>
         </p:txBody>
       </p:sp>
@@ -8363,7 +8483,7 @@
 </file>
 
 <file path=ppt/slides/slide9.xml><?xml version="1.0" encoding="utf-8"?>
-<p:sld xmlns:a="http://schemas.openxmlformats.org/drawingml/2006/main" xmlns:p="http://schemas.openxmlformats.org/presentationml/2006/main" xmlns:r="http://schemas.openxmlformats.org/officeDocument/2006/relationships">
+<p:sld xmlns:a="http://schemas.openxmlformats.org/drawingml/2006/main" xmlns:r="http://schemas.openxmlformats.org/officeDocument/2006/relationships" xmlns:p="http://schemas.openxmlformats.org/presentationml/2006/main">
   <p:cSld>
     <p:spTree>
       <p:nvGrpSpPr>
@@ -8371,7 +8491,14 @@
         <p:cNvGrpSpPr/>
         <p:nvPr/>
       </p:nvGrpSpPr>
-      <p:grpSpPr/>
+      <p:grpSpPr>
+        <a:xfrm>
+          <a:off x="0" y="0"/>
+          <a:ext cx="0" cy="0"/>
+          <a:chOff x="0" y="0"/>
+          <a:chExt cx="0" cy="0"/>
+        </a:xfrm>
+      </p:grpSpPr>
       <p:sp>
         <p:nvSpPr>
           <p:cNvPr id="2" name="Rectangle 1"/>
@@ -8413,6 +8540,7 @@
           <a:lstStyle/>
           <a:p>
             <a:pPr algn="ctr"/>
+            <a:endParaRPr/>
           </a:p>
         </p:txBody>
       </p:sp>
@@ -8499,6 +8627,7 @@
           <a:lstStyle/>
           <a:p>
             <a:pPr algn="ctr"/>
+            <a:endParaRPr/>
           </a:p>
         </p:txBody>
       </p:sp>
@@ -8559,16 +8688,52 @@
         <a:graphic>
           <a:graphicData uri="http://schemas.openxmlformats.org/drawingml/2006/table">
             <a:tbl>
-              <a:tblPr firstRow="0" bandRow="0">
+              <a:tblPr>
                 <a:tableStyleId>{2D5ABB26-0587-4C30-8999-92F81FD0307C}</a:tableStyleId>
               </a:tblPr>
               <a:tblGrid>
-                <a:gridCol w="2770632"/>
-                <a:gridCol w="1627632"/>
-                <a:gridCol w="1627632"/>
-                <a:gridCol w="1627632"/>
-                <a:gridCol w="1627632"/>
-                <a:gridCol w="1627632"/>
+                <a:gridCol w="2770632">
+                  <a:extLst>
+                    <a:ext uri="{9D8B030D-6E8A-4147-A177-3AD203B41FA5}">
+                      <a16:colId xmlns:a16="http://schemas.microsoft.com/office/drawing/2014/main" val="20000"/>
+                    </a:ext>
+                  </a:extLst>
+                </a:gridCol>
+                <a:gridCol w="1627632">
+                  <a:extLst>
+                    <a:ext uri="{9D8B030D-6E8A-4147-A177-3AD203B41FA5}">
+                      <a16:colId xmlns:a16="http://schemas.microsoft.com/office/drawing/2014/main" val="20001"/>
+                    </a:ext>
+                  </a:extLst>
+                </a:gridCol>
+                <a:gridCol w="1627632">
+                  <a:extLst>
+                    <a:ext uri="{9D8B030D-6E8A-4147-A177-3AD203B41FA5}">
+                      <a16:colId xmlns:a16="http://schemas.microsoft.com/office/drawing/2014/main" val="20002"/>
+                    </a:ext>
+                  </a:extLst>
+                </a:gridCol>
+                <a:gridCol w="1627632">
+                  <a:extLst>
+                    <a:ext uri="{9D8B030D-6E8A-4147-A177-3AD203B41FA5}">
+                      <a16:colId xmlns:a16="http://schemas.microsoft.com/office/drawing/2014/main" val="20003"/>
+                    </a:ext>
+                  </a:extLst>
+                </a:gridCol>
+                <a:gridCol w="1627632">
+                  <a:extLst>
+                    <a:ext uri="{9D8B030D-6E8A-4147-A177-3AD203B41FA5}">
+                      <a16:colId xmlns:a16="http://schemas.microsoft.com/office/drawing/2014/main" val="20004"/>
+                    </a:ext>
+                  </a:extLst>
+                </a:gridCol>
+                <a:gridCol w="1627632">
+                  <a:extLst>
+                    <a:ext uri="{9D8B030D-6E8A-4147-A177-3AD203B41FA5}">
+                      <a16:colId xmlns:a16="http://schemas.microsoft.com/office/drawing/2014/main" val="20005"/>
+                    </a:ext>
+                  </a:extLst>
+                </a:gridCol>
               </a:tblGrid>
               <a:tr h="475488">
                 <a:tc>
@@ -8577,18 +8742,10 @@
                     <a:lstStyle/>
                     <a:p>
                       <a:pPr algn="l"/>
-                      <a:r>
-                        <a:rPr sz="1500" b="1">
-                          <a:solidFill>
-                            <a:srgbClr val="111111"/>
-                          </a:solidFill>
-                          <a:latin typeface="Times New Roman"/>
-                        </a:rPr>
-                        <a:t/>
-                      </a:r>
+                      <a:endParaRPr/>
                     </a:p>
                   </a:txBody>
-                  <a:tcPr anchor="ctr" marL="127000" marR="76200" marT="25400" marB="25400">
+                  <a:tcPr marL="127000" marR="76200" marT="25400" marB="25400" anchor="ctr">
                     <a:noFill/>
                   </a:tcPr>
                 </a:tc>
@@ -8609,7 +8766,7 @@
                       </a:r>
                     </a:p>
                   </a:txBody>
-                  <a:tcPr anchor="ctr" marL="127000" marR="76200" marT="25400" marB="25400">
+                  <a:tcPr marL="127000" marR="76200" marT="25400" marB="25400" anchor="ctr">
                     <a:noFill/>
                   </a:tcPr>
                 </a:tc>
@@ -8630,7 +8787,7 @@
                       </a:r>
                     </a:p>
                   </a:txBody>
-                  <a:tcPr anchor="ctr" marL="127000" marR="76200" marT="25400" marB="25400">
+                  <a:tcPr marL="127000" marR="76200" marT="25400" marB="25400" anchor="ctr">
                     <a:noFill/>
                   </a:tcPr>
                 </a:tc>
@@ -8651,7 +8808,7 @@
                       </a:r>
                     </a:p>
                   </a:txBody>
-                  <a:tcPr anchor="ctr" marL="127000" marR="76200" marT="25400" marB="25400">
+                  <a:tcPr marL="127000" marR="76200" marT="25400" marB="25400" anchor="ctr">
                     <a:noFill/>
                   </a:tcPr>
                 </a:tc>
@@ -8672,7 +8829,7 @@
                       </a:r>
                     </a:p>
                   </a:txBody>
-                  <a:tcPr anchor="ctr" marL="127000" marR="76200" marT="25400" marB="25400">
+                  <a:tcPr marL="127000" marR="76200" marT="25400" marB="25400" anchor="ctr">
                     <a:noFill/>
                   </a:tcPr>
                 </a:tc>
@@ -8693,10 +8850,15 @@
                       </a:r>
                     </a:p>
                   </a:txBody>
-                  <a:tcPr anchor="ctr" marL="127000" marR="76200" marT="25400" marB="25400">
+                  <a:tcPr marL="127000" marR="76200" marT="25400" marB="25400" anchor="ctr">
                     <a:noFill/>
                   </a:tcPr>
                 </a:tc>
+                <a:extLst>
+                  <a:ext uri="{0D108BD9-81ED-4DB2-BD59-A6C34878D82A}">
+                    <a16:rowId xmlns:a16="http://schemas.microsoft.com/office/drawing/2014/main" val="10000"/>
+                  </a:ext>
+                </a:extLst>
               </a:tr>
               <a:tr h="475488">
                 <a:tc>
@@ -8716,7 +8878,7 @@
                       </a:r>
                     </a:p>
                   </a:txBody>
-                  <a:tcPr anchor="ctr" marL="127000" marR="76200" marT="25400" marB="25400">
+                  <a:tcPr marL="127000" marR="76200" marT="25400" marB="25400" anchor="ctr">
                     <a:noFill/>
                   </a:tcPr>
                 </a:tc>
@@ -8737,7 +8899,7 @@
                       </a:r>
                     </a:p>
                   </a:txBody>
-                  <a:tcPr anchor="ctr" marL="127000" marR="76200" marT="25400" marB="25400">
+                  <a:tcPr marL="127000" marR="76200" marT="25400" marB="25400" anchor="ctr">
                     <a:noFill/>
                   </a:tcPr>
                 </a:tc>
@@ -8758,7 +8920,7 @@
                       </a:r>
                     </a:p>
                   </a:txBody>
-                  <a:tcPr anchor="ctr" marL="127000" marR="76200" marT="25400" marB="25400">
+                  <a:tcPr marL="127000" marR="76200" marT="25400" marB="25400" anchor="ctr">
                     <a:noFill/>
                   </a:tcPr>
                 </a:tc>
@@ -8779,7 +8941,7 @@
                       </a:r>
                     </a:p>
                   </a:txBody>
-                  <a:tcPr anchor="ctr" marL="127000" marR="76200" marT="25400" marB="25400">
+                  <a:tcPr marL="127000" marR="76200" marT="25400" marB="25400" anchor="ctr">
                     <a:noFill/>
                   </a:tcPr>
                 </a:tc>
@@ -8800,7 +8962,7 @@
                       </a:r>
                     </a:p>
                   </a:txBody>
-                  <a:tcPr anchor="ctr" marL="127000" marR="76200" marT="25400" marB="25400">
+                  <a:tcPr marL="127000" marR="76200" marT="25400" marB="25400" anchor="ctr">
                     <a:noFill/>
                   </a:tcPr>
                 </a:tc>
@@ -8821,10 +8983,15 @@
                       </a:r>
                     </a:p>
                   </a:txBody>
-                  <a:tcPr anchor="ctr" marL="127000" marR="76200" marT="25400" marB="25400">
+                  <a:tcPr marL="127000" marR="76200" marT="25400" marB="25400" anchor="ctr">
                     <a:noFill/>
                   </a:tcPr>
                 </a:tc>
+                <a:extLst>
+                  <a:ext uri="{0D108BD9-81ED-4DB2-BD59-A6C34878D82A}">
+                    <a16:rowId xmlns:a16="http://schemas.microsoft.com/office/drawing/2014/main" val="10001"/>
+                  </a:ext>
+                </a:extLst>
               </a:tr>
               <a:tr h="475488">
                 <a:tc>
@@ -8844,7 +9011,7 @@
                       </a:r>
                     </a:p>
                   </a:txBody>
-                  <a:tcPr anchor="ctr" marL="127000" marR="76200" marT="25400" marB="25400">
+                  <a:tcPr marL="127000" marR="76200" marT="25400" marB="25400" anchor="ctr">
                     <a:noFill/>
                   </a:tcPr>
                 </a:tc>
@@ -8865,7 +9032,7 @@
                       </a:r>
                     </a:p>
                   </a:txBody>
-                  <a:tcPr anchor="ctr" marL="127000" marR="76200" marT="25400" marB="25400">
+                  <a:tcPr marL="127000" marR="76200" marT="25400" marB="25400" anchor="ctr">
                     <a:noFill/>
                   </a:tcPr>
                 </a:tc>
@@ -8886,7 +9053,7 @@
                       </a:r>
                     </a:p>
                   </a:txBody>
-                  <a:tcPr anchor="ctr" marL="127000" marR="76200" marT="25400" marB="25400">
+                  <a:tcPr marL="127000" marR="76200" marT="25400" marB="25400" anchor="ctr">
                     <a:noFill/>
                   </a:tcPr>
                 </a:tc>
@@ -8907,7 +9074,7 @@
                       </a:r>
                     </a:p>
                   </a:txBody>
-                  <a:tcPr anchor="ctr" marL="127000" marR="76200" marT="25400" marB="25400">
+                  <a:tcPr marL="127000" marR="76200" marT="25400" marB="25400" anchor="ctr">
                     <a:noFill/>
                   </a:tcPr>
                 </a:tc>
@@ -8928,7 +9095,7 @@
                       </a:r>
                     </a:p>
                   </a:txBody>
-                  <a:tcPr anchor="ctr" marL="127000" marR="76200" marT="25400" marB="25400">
+                  <a:tcPr marL="127000" marR="76200" marT="25400" marB="25400" anchor="ctr">
                     <a:noFill/>
                   </a:tcPr>
                 </a:tc>
@@ -8949,10 +9116,15 @@
                       </a:r>
                     </a:p>
                   </a:txBody>
-                  <a:tcPr anchor="ctr" marL="127000" marR="76200" marT="25400" marB="25400">
+                  <a:tcPr marL="127000" marR="76200" marT="25400" marB="25400" anchor="ctr">
                     <a:noFill/>
                   </a:tcPr>
                 </a:tc>
+                <a:extLst>
+                  <a:ext uri="{0D108BD9-81ED-4DB2-BD59-A6C34878D82A}">
+                    <a16:rowId xmlns:a16="http://schemas.microsoft.com/office/drawing/2014/main" val="10002"/>
+                  </a:ext>
+                </a:extLst>
               </a:tr>
               <a:tr h="475488">
                 <a:tc>
@@ -8972,7 +9144,7 @@
                       </a:r>
                     </a:p>
                   </a:txBody>
-                  <a:tcPr anchor="ctr" marL="127000" marR="76200" marT="25400" marB="25400">
+                  <a:tcPr marL="127000" marR="76200" marT="25400" marB="25400" anchor="ctr">
                     <a:noFill/>
                   </a:tcPr>
                 </a:tc>
@@ -8993,7 +9165,7 @@
                       </a:r>
                     </a:p>
                   </a:txBody>
-                  <a:tcPr anchor="ctr" marL="127000" marR="76200" marT="25400" marB="25400">
+                  <a:tcPr marL="127000" marR="76200" marT="25400" marB="25400" anchor="ctr">
                     <a:noFill/>
                   </a:tcPr>
                 </a:tc>
@@ -9014,7 +9186,7 @@
                       </a:r>
                     </a:p>
                   </a:txBody>
-                  <a:tcPr anchor="ctr" marL="127000" marR="76200" marT="25400" marB="25400">
+                  <a:tcPr marL="127000" marR="76200" marT="25400" marB="25400" anchor="ctr">
                     <a:noFill/>
                   </a:tcPr>
                 </a:tc>
@@ -9035,7 +9207,7 @@
                       </a:r>
                     </a:p>
                   </a:txBody>
-                  <a:tcPr anchor="ctr" marL="127000" marR="76200" marT="25400" marB="25400">
+                  <a:tcPr marL="127000" marR="76200" marT="25400" marB="25400" anchor="ctr">
                     <a:noFill/>
                   </a:tcPr>
                 </a:tc>
@@ -9056,7 +9228,7 @@
                       </a:r>
                     </a:p>
                   </a:txBody>
-                  <a:tcPr anchor="ctr" marL="127000" marR="76200" marT="25400" marB="25400">
+                  <a:tcPr marL="127000" marR="76200" marT="25400" marB="25400" anchor="ctr">
                     <a:noFill/>
                   </a:tcPr>
                 </a:tc>
@@ -9077,10 +9249,15 @@
                       </a:r>
                     </a:p>
                   </a:txBody>
-                  <a:tcPr anchor="ctr" marL="127000" marR="76200" marT="25400" marB="25400">
+                  <a:tcPr marL="127000" marR="76200" marT="25400" marB="25400" anchor="ctr">
                     <a:noFill/>
                   </a:tcPr>
                 </a:tc>
+                <a:extLst>
+                  <a:ext uri="{0D108BD9-81ED-4DB2-BD59-A6C34878D82A}">
+                    <a16:rowId xmlns:a16="http://schemas.microsoft.com/office/drawing/2014/main" val="10003"/>
+                  </a:ext>
+                </a:extLst>
               </a:tr>
               <a:tr h="475488">
                 <a:tc>
@@ -9100,7 +9277,7 @@
                       </a:r>
                     </a:p>
                   </a:txBody>
-                  <a:tcPr anchor="ctr" marL="127000" marR="76200" marT="25400" marB="25400">
+                  <a:tcPr marL="127000" marR="76200" marT="25400" marB="25400" anchor="ctr">
                     <a:noFill/>
                   </a:tcPr>
                 </a:tc>
@@ -9121,7 +9298,7 @@
                       </a:r>
                     </a:p>
                   </a:txBody>
-                  <a:tcPr anchor="ctr" marL="127000" marR="76200" marT="25400" marB="25400">
+                  <a:tcPr marL="127000" marR="76200" marT="25400" marB="25400" anchor="ctr">
                     <a:noFill/>
                   </a:tcPr>
                 </a:tc>
@@ -9142,7 +9319,7 @@
                       </a:r>
                     </a:p>
                   </a:txBody>
-                  <a:tcPr anchor="ctr" marL="127000" marR="76200" marT="25400" marB="25400">
+                  <a:tcPr marL="127000" marR="76200" marT="25400" marB="25400" anchor="ctr">
                     <a:noFill/>
                   </a:tcPr>
                 </a:tc>
@@ -9163,7 +9340,7 @@
                       </a:r>
                     </a:p>
                   </a:txBody>
-                  <a:tcPr anchor="ctr" marL="127000" marR="76200" marT="25400" marB="25400">
+                  <a:tcPr marL="127000" marR="76200" marT="25400" marB="25400" anchor="ctr">
                     <a:noFill/>
                   </a:tcPr>
                 </a:tc>
@@ -9184,7 +9361,7 @@
                       </a:r>
                     </a:p>
                   </a:txBody>
-                  <a:tcPr anchor="ctr" marL="127000" marR="76200" marT="25400" marB="25400">
+                  <a:tcPr marL="127000" marR="76200" marT="25400" marB="25400" anchor="ctr">
                     <a:noFill/>
                   </a:tcPr>
                 </a:tc>
@@ -9205,10 +9382,15 @@
                       </a:r>
                     </a:p>
                   </a:txBody>
-                  <a:tcPr anchor="ctr" marL="127000" marR="76200" marT="25400" marB="25400">
+                  <a:tcPr marL="127000" marR="76200" marT="25400" marB="25400" anchor="ctr">
                     <a:noFill/>
                   </a:tcPr>
                 </a:tc>
+                <a:extLst>
+                  <a:ext uri="{0D108BD9-81ED-4DB2-BD59-A6C34878D82A}">
+                    <a16:rowId xmlns:a16="http://schemas.microsoft.com/office/drawing/2014/main" val="10004"/>
+                  </a:ext>
+                </a:extLst>
               </a:tr>
             </a:tbl>
           </a:graphicData>
@@ -9255,6 +9437,7 @@
           <a:lstStyle/>
           <a:p>
             <a:pPr algn="ctr"/>
+            <a:endParaRPr/>
           </a:p>
         </p:txBody>
       </p:sp>
@@ -9299,6 +9482,7 @@
           <a:lstStyle/>
           <a:p>
             <a:pPr algn="ctr"/>
+            <a:endParaRPr/>
           </a:p>
         </p:txBody>
       </p:sp>
@@ -9343,6 +9527,7 @@
           <a:lstStyle/>
           <a:p>
             <a:pPr algn="ctr"/>
+            <a:endParaRPr/>
           </a:p>
         </p:txBody>
       </p:sp>

</xml_diff>